<commit_message>
Reflejar el asistente, los correos y la accesibilidad en la EA2 y en la ERS
Tras integrar la rama Brahams/entregable, el sistema tiene piezas que la
presentacion y el documento de requerimientos no mencionaban.

Presentacion EA2:
- Lamina nueva "Atender al cliente sin sumar personal": el asistente
  Pelusa, los ocho avisos por correo y la revision de accesibilidad
- Cifras recontadas ejecutando el proyecto: 137 pruebas con 346
  aserciones, 32 rutas propias y 14 servicios de dominio

Documento de requerimientos:
- RF-18, asistente de atencion en el sitio, con el limite de que solo
  consulta los datos del cliente conectado (RN-01, RN-04)
- RF-19, avisos automaticos por correo y buzon de contacto etiquetado
- Trazabilidad y entregas actualizadas con los dos requerimientos

Co-Authored-By: Claude Opus 5 <noreply@anthropic.com>
Claude-Session: https://claude.ai/code/session_01SBNMpgU4DA2arm6qA7genT
</commit_message>
<xml_diff>
--- a/docs/presentacion/EA2_VetPetConnect.pptx
+++ b/docs/presentacion/EA2_VetPetConnect.pptx
@@ -17,9 +17,10 @@
     <p:sldId id="265" r:id="rId11"/>
     <p:sldId id="266" r:id="rId12"/>
     <p:sldId id="267" r:id="rId13"/>
+    <p:sldId id="268" r:id="rId14"/>
   </p:sldIdLst>
   <p:notesMasterIdLst>
-    <p:notesMasterId r:id="rId14"/>
+    <p:notesMasterId r:id="rId15"/>
   </p:notesMasterIdLst>
   <p:sldSz cx="12192000" cy="6858000"/>
   <p:notesSz cx="6858000" cy="12192000"/>
@@ -689,7 +690,7 @@
           <a:p>
             <a:r>
               <a:rPr lang="en-US" dirty="0"/>
-              <a:t>Si el jurado pide demostración en vivo: la suite corre en siete segundos y el recorrido completo de compra se puede mostrar en el navegador.</a:t>
+              <a:t>Si preguntan si el chatbot usa IA: no, y es una decisión, no una carencia. Un motor de palabras clave con una configuración revisable es auditable, no inventa respuestas y no tiene costo por consulta. Para las preguntas frecuentes de una veterinaria es suficiente.</a:t>
             </a:r>
             <a:endParaRPr lang="en-US" dirty="0"/>
           </a:p>
@@ -777,7 +778,7 @@
           <a:p>
             <a:r>
               <a:rPr lang="en-US" dirty="0"/>
-              <a:t>Cierre. Si hay una sola idea que quede: las reglas del negocio están escritas en el sistema y se comprueban solas. Eso es lo que separa un prototipo de un producto.</a:t>
+              <a:t>Si el jurado pide demostración en vivo: la suite corre en siete segundos y el recorrido completo de compra se puede mostrar en el navegador.</a:t>
             </a:r>
             <a:endParaRPr lang="en-US" dirty="0"/>
           </a:p>
@@ -801,6 +802,94 @@
             <a:fld id="{F7021451-1387-4CA6-816F-3879F97B5CBC}" type="slidenum">
               <a:rPr lang="en-US"/>
               <a:t>12</a:t>
+            </a:fld>
+            <a:endParaRPr lang="en-US"/>
+          </a:p>
+        </p:txBody>
+      </p:sp>
+    </p:spTree>
+    <p:extLst>
+      <p:ext uri="{BB962C8B-B14F-4D97-AF65-F5344CB8AC3E}">
+        <p14:creationId xmlns:p14="http://schemas.microsoft.com/office/powerpoint/2010/main" val="1024086991"/>
+      </p:ext>
+    </p:extLst>
+  </p:cSld>
+  <p:clrMapOvr>
+    <a:masterClrMapping/>
+  </p:clrMapOvr>
+</p:notes>
+</file>
+
+<file path=ppt/notesSlides/notesSlide13.xml><?xml version="1.0" encoding="utf-8"?>
+<p:notes xmlns:a="http://schemas.openxmlformats.org/drawingml/2006/main" xmlns:r="http://schemas.openxmlformats.org/officeDocument/2006/relationships" xmlns:p="http://schemas.openxmlformats.org/presentationml/2006/main">
+  <p:cSld>
+    <p:spTree>
+      <p:nvGrpSpPr>
+        <p:cNvPr id="1" name=""/>
+        <p:cNvGrpSpPr/>
+        <p:nvPr/>
+      </p:nvGrpSpPr>
+      <p:grpSpPr>
+        <a:xfrm>
+          <a:off x="0" y="0"/>
+          <a:ext cx="0" cy="0"/>
+          <a:chOff x="0" y="0"/>
+          <a:chExt cx="0" cy="0"/>
+        </a:xfrm>
+      </p:grpSpPr>
+      <p:sp>
+        <p:nvSpPr>
+          <p:cNvPr id="2" name="Slide Image Placeholder 1"/>
+          <p:cNvSpPr>
+            <a:spLocks noGrp="1" noRot="1" noChangeAspect="1"/>
+          </p:cNvSpPr>
+          <p:nvPr>
+            <p:ph type="sldImg"/>
+          </p:nvPr>
+        </p:nvSpPr>
+        <p:spPr/>
+      </p:sp>
+      <p:sp>
+        <p:nvSpPr>
+          <p:cNvPr id="3" name="Notes Placeholder 2"/>
+          <p:cNvSpPr>
+            <a:spLocks noGrp="1"/>
+          </p:cNvSpPr>
+          <p:nvPr>
+            <p:ph type="body" idx="1"/>
+          </p:nvPr>
+        </p:nvSpPr>
+        <p:spPr/>
+        <p:txBody>
+          <a:bodyPr/>
+          <a:lstStyle/>
+          <a:p>
+            <a:r>
+              <a:rPr lang="en-US" dirty="0"/>
+              <a:t>Cierre. Si hay una sola idea que quede: las reglas del negocio están escritas en el sistema y se comprueban solas. Eso es lo que separa un prototipo de un producto.</a:t>
+            </a:r>
+            <a:endParaRPr lang="en-US" dirty="0"/>
+          </a:p>
+        </p:txBody>
+      </p:sp>
+      <p:sp>
+        <p:nvSpPr>
+          <p:cNvPr id="4" name="Slide Number Placeholder 3"/>
+          <p:cNvSpPr>
+            <a:spLocks noGrp="1"/>
+          </p:cNvSpPr>
+          <p:nvPr>
+            <p:ph type="sldNum" sz="quarter" idx="10"/>
+          </p:nvPr>
+        </p:nvSpPr>
+        <p:spPr/>
+        <p:txBody>
+          <a:bodyPr/>
+          <a:lstStyle/>
+          <a:p>
+            <a:fld id="{F7021451-1387-4CA6-816F-3879F97B5CBC}" type="slidenum">
+              <a:rPr lang="en-US"/>
+              <a:t>13</a:t>
             </a:fld>
             <a:endParaRPr lang="en-US"/>
           </a:p>
@@ -2391,7 +2480,7 @@
                 <a:ea typeface="Cambria" pitchFamily="34" charset="-122"/>
                 <a:cs typeface="Cambria" pitchFamily="34" charset="-120"/>
               </a:rPr>
-              <a:t>12</a:t>
+              <a:t>14</a:t>
             </a:r>
             <a:endParaRPr lang="en-US" sz="3000" dirty="0"/>
           </a:p>
@@ -2496,7 +2585,7 @@
                 <a:ea typeface="Cambria" pitchFamily="34" charset="-122"/>
                 <a:cs typeface="Cambria" pitchFamily="34" charset="-120"/>
               </a:rPr>
-              <a:t>28</a:t>
+              <a:t>32</a:t>
             </a:r>
             <a:endParaRPr lang="en-US" sz="3000" dirty="0"/>
           </a:p>
@@ -3123,7 +3212,7 @@
                 <a:ea typeface="Cambria" pitchFamily="34" charset="-122"/>
                 <a:cs typeface="Cambria" pitchFamily="34" charset="-120"/>
               </a:rPr>
-              <a:t>Lo que se puede comprobar hoy</a:t>
+              <a:t>Atender al cliente sin sumar personal</a:t>
             </a:r>
             <a:endParaRPr lang="en-US" sz="3200" dirty="0"/>
           </a:p>
@@ -3162,7 +3251,7 @@
                 <a:ea typeface="Calibri" pitchFamily="34" charset="-122"/>
                 <a:cs typeface="Calibri" pitchFamily="34" charset="-120"/>
               </a:rPr>
-              <a:t>No es una maqueta: es una aplicación que se ejecuta y se prueba</a:t>
+              <a:t>Tres piezas que incorporó el último incremento</a:t>
             </a:r>
             <a:endParaRPr lang="en-US" sz="1400" dirty="0"/>
           </a:p>
@@ -3176,12 +3265,453 @@
         </p:nvSpPr>
         <p:spPr>
           <a:xfrm>
-            <a:off x="640080" y="1682496"/>
-            <a:ext cx="5336896" cy="1828800"/>
+            <a:off x="640080" y="1719072"/>
+            <a:ext cx="3503066" cy="2432304"/>
           </a:xfrm>
           <a:prstGeom prst="roundRect">
             <a:avLst>
-              <a:gd name="adj" fmla="val 2500"/>
+              <a:gd name="adj" fmla="val 1880"/>
+            </a:avLst>
+          </a:prstGeom>
+          <a:solidFill>
+            <a:srgbClr val="EEF5F1"/>
+          </a:solidFill>
+          <a:ln w="12700">
+            <a:solidFill>
+              <a:srgbClr val="D9E5DF"/>
+            </a:solidFill>
+            <a:prstDash val="solid"/>
+          </a:ln>
+        </p:spPr>
+      </p:sp>
+      <p:sp>
+        <p:nvSpPr>
+          <p:cNvPr id="5" name="Text 3"/>
+          <p:cNvSpPr txBox="1"/>
+          <p:nvPr/>
+        </p:nvSpPr>
+        <p:spPr>
+          <a:xfrm>
+            <a:off x="896112" y="1920240"/>
+            <a:ext cx="2991002" cy="274320"/>
+          </a:xfrm>
+          <a:prstGeom prst="rect">
+            <a:avLst/>
+          </a:prstGeom>
+          <a:noFill/>
+          <a:ln/>
+        </p:spPr>
+        <p:txBody>
+          <a:bodyPr wrap="square" lIns="0" tIns="0" rIns="0" bIns="0" rtlCol="0" anchor="ctr"/>
+          <a:lstStyle/>
+          <a:p>
+            <a:pPr indent="0" marL="0">
+              <a:buNone/>
+            </a:pPr>
+            <a:r>
+              <a:rPr lang="en-US" sz="1050" b="1" dirty="0">
+                <a:solidFill>
+                  <a:srgbClr val="2C7A6B"/>
+                </a:solidFill>
+                <a:latin typeface="Calibri" pitchFamily="34" charset="0"/>
+                <a:ea typeface="Calibri" pitchFamily="34" charset="-122"/>
+                <a:cs typeface="Calibri" pitchFamily="34" charset="-120"/>
+              </a:rPr>
+              <a:t>ASISTENTE DEL SITIO</a:t>
+            </a:r>
+            <a:endParaRPr lang="en-US" sz="1050" dirty="0"/>
+          </a:p>
+        </p:txBody>
+      </p:sp>
+      <p:sp>
+        <p:nvSpPr>
+          <p:cNvPr id="6" name="Text 4"/>
+          <p:cNvSpPr txBox="1"/>
+          <p:nvPr/>
+        </p:nvSpPr>
+        <p:spPr>
+          <a:xfrm>
+            <a:off x="896112" y="2212848"/>
+            <a:ext cx="2991002" cy="365760"/>
+          </a:xfrm>
+          <a:prstGeom prst="rect">
+            <a:avLst/>
+          </a:prstGeom>
+          <a:noFill/>
+          <a:ln/>
+        </p:spPr>
+        <p:txBody>
+          <a:bodyPr wrap="square" lIns="0" tIns="0" rIns="0" bIns="0" rtlCol="0" anchor="ctr"/>
+          <a:lstStyle/>
+          <a:p>
+            <a:pPr indent="0" marL="0">
+              <a:buNone/>
+            </a:pPr>
+            <a:r>
+              <a:rPr lang="en-US" sz="1600" b="1" dirty="0">
+                <a:solidFill>
+                  <a:srgbClr val="14524A"/>
+                </a:solidFill>
+                <a:latin typeface="Cambria" pitchFamily="34" charset="0"/>
+                <a:ea typeface="Cambria" pitchFamily="34" charset="-122"/>
+                <a:cs typeface="Cambria" pitchFamily="34" charset="-120"/>
+              </a:rPr>
+              <a:t>Pelusa responde sola</a:t>
+            </a:r>
+            <a:endParaRPr lang="en-US" sz="1600" dirty="0"/>
+          </a:p>
+        </p:txBody>
+      </p:sp>
+      <p:sp>
+        <p:nvSpPr>
+          <p:cNvPr id="7" name="Text 5"/>
+          <p:cNvSpPr txBox="1"/>
+          <p:nvPr/>
+        </p:nvSpPr>
+        <p:spPr>
+          <a:xfrm>
+            <a:off x="896112" y="2651760"/>
+            <a:ext cx="2991002" cy="1298448"/>
+          </a:xfrm>
+          <a:prstGeom prst="rect">
+            <a:avLst/>
+          </a:prstGeom>
+          <a:noFill/>
+          <a:ln/>
+        </p:spPr>
+        <p:txBody>
+          <a:bodyPr wrap="square" lIns="0" tIns="0" rIns="0" bIns="0" rtlCol="0" anchor="t"/>
+          <a:lstStyle/>
+          <a:p>
+            <a:pPr indent="0" marL="0">
+              <a:lnSpc>
+                <a:spcPts val="1740"/>
+              </a:lnSpc>
+              <a:buNone/>
+            </a:pPr>
+            <a:r>
+              <a:rPr lang="en-US" sz="1200" dirty="0">
+                <a:solidFill>
+                  <a:srgbClr val="1C2321"/>
+                </a:solidFill>
+                <a:latin typeface="Calibri" pitchFamily="34" charset="0"/>
+                <a:ea typeface="Calibri" pitchFamily="34" charset="-122"/>
+                <a:cs typeface="Calibri" pitchFamily="34" charset="-120"/>
+              </a:rPr>
+              <a:t>Entiende 14 tipos de pregunta en español y contesta con los datos de la propia cuenta: en qué va el pedido, cuándo llega el despacho, qué vacuna toca. Ocho temas de menú para quien prefiere no escribir.</a:t>
+            </a:r>
+            <a:endParaRPr lang="en-US" sz="1200" dirty="0"/>
+          </a:p>
+        </p:txBody>
+      </p:sp>
+      <p:sp>
+        <p:nvSpPr>
+          <p:cNvPr id="8" name="Shape 6"/>
+          <p:cNvSpPr/>
+          <p:nvPr/>
+        </p:nvSpPr>
+        <p:spPr>
+          <a:xfrm>
+            <a:off x="4344314" y="1719072"/>
+            <a:ext cx="3503066" cy="2432304"/>
+          </a:xfrm>
+          <a:prstGeom prst="roundRect">
+            <a:avLst>
+              <a:gd name="adj" fmla="val 1880"/>
+            </a:avLst>
+          </a:prstGeom>
+          <a:solidFill>
+            <a:srgbClr val="EEF5F1"/>
+          </a:solidFill>
+          <a:ln w="12700">
+            <a:solidFill>
+              <a:srgbClr val="D9E5DF"/>
+            </a:solidFill>
+            <a:prstDash val="solid"/>
+          </a:ln>
+        </p:spPr>
+      </p:sp>
+      <p:sp>
+        <p:nvSpPr>
+          <p:cNvPr id="9" name="Text 7"/>
+          <p:cNvSpPr txBox="1"/>
+          <p:nvPr/>
+        </p:nvSpPr>
+        <p:spPr>
+          <a:xfrm>
+            <a:off x="4600346" y="1920240"/>
+            <a:ext cx="2991002" cy="274320"/>
+          </a:xfrm>
+          <a:prstGeom prst="rect">
+            <a:avLst/>
+          </a:prstGeom>
+          <a:noFill/>
+          <a:ln/>
+        </p:spPr>
+        <p:txBody>
+          <a:bodyPr wrap="square" lIns="0" tIns="0" rIns="0" bIns="0" rtlCol="0" anchor="ctr"/>
+          <a:lstStyle/>
+          <a:p>
+            <a:pPr indent="0" marL="0">
+              <a:buNone/>
+            </a:pPr>
+            <a:r>
+              <a:rPr lang="en-US" sz="1050" b="1" dirty="0">
+                <a:solidFill>
+                  <a:srgbClr val="E8A33D"/>
+                </a:solidFill>
+                <a:latin typeface="Calibri" pitchFamily="34" charset="0"/>
+                <a:ea typeface="Calibri" pitchFamily="34" charset="-122"/>
+                <a:cs typeface="Calibri" pitchFamily="34" charset="-120"/>
+              </a:rPr>
+              <a:t>CORREOS</a:t>
+            </a:r>
+            <a:endParaRPr lang="en-US" sz="1050" dirty="0"/>
+          </a:p>
+        </p:txBody>
+      </p:sp>
+      <p:sp>
+        <p:nvSpPr>
+          <p:cNvPr id="10" name="Text 8"/>
+          <p:cNvSpPr txBox="1"/>
+          <p:nvPr/>
+        </p:nvSpPr>
+        <p:spPr>
+          <a:xfrm>
+            <a:off x="4600346" y="2212848"/>
+            <a:ext cx="2991002" cy="365760"/>
+          </a:xfrm>
+          <a:prstGeom prst="rect">
+            <a:avLst/>
+          </a:prstGeom>
+          <a:noFill/>
+          <a:ln/>
+        </p:spPr>
+        <p:txBody>
+          <a:bodyPr wrap="square" lIns="0" tIns="0" rIns="0" bIns="0" rtlCol="0" anchor="ctr"/>
+          <a:lstStyle/>
+          <a:p>
+            <a:pPr indent="0" marL="0">
+              <a:buNone/>
+            </a:pPr>
+            <a:r>
+              <a:rPr lang="en-US" sz="1600" b="1" dirty="0">
+                <a:solidFill>
+                  <a:srgbClr val="14524A"/>
+                </a:solidFill>
+                <a:latin typeface="Cambria" pitchFamily="34" charset="0"/>
+                <a:ea typeface="Cambria" pitchFamily="34" charset="-122"/>
+                <a:cs typeface="Cambria" pitchFamily="34" charset="-120"/>
+              </a:rPr>
+              <a:t>Ocho avisos automáticos</a:t>
+            </a:r>
+            <a:endParaRPr lang="en-US" sz="1600" dirty="0"/>
+          </a:p>
+        </p:txBody>
+      </p:sp>
+      <p:sp>
+        <p:nvSpPr>
+          <p:cNvPr id="11" name="Text 9"/>
+          <p:cNvSpPr txBox="1"/>
+          <p:nvPr/>
+        </p:nvSpPr>
+        <p:spPr>
+          <a:xfrm>
+            <a:off x="4600346" y="2651760"/>
+            <a:ext cx="2991002" cy="1298448"/>
+          </a:xfrm>
+          <a:prstGeom prst="rect">
+            <a:avLst/>
+          </a:prstGeom>
+          <a:noFill/>
+          <a:ln/>
+        </p:spPr>
+        <p:txBody>
+          <a:bodyPr wrap="square" lIns="0" tIns="0" rIns="0" bIns="0" rtlCol="0" anchor="t"/>
+          <a:lstStyle/>
+          <a:p>
+            <a:pPr indent="0" marL="0">
+              <a:lnSpc>
+                <a:spcPts val="1740"/>
+              </a:lnSpc>
+              <a:buNone/>
+            </a:pPr>
+            <a:r>
+              <a:rPr lang="en-US" sz="1200" dirty="0">
+                <a:solidFill>
+                  <a:srgbClr val="1C2321"/>
+                </a:solidFill>
+                <a:latin typeface="Calibri" pitchFamily="34" charset="0"/>
+                <a:ea typeface="Calibri" pitchFamily="34" charset="-122"/>
+                <a:cs typeface="Calibri" pitchFamily="34" charset="-120"/>
+              </a:rPr>
+              <a:t>Bienvenida, pedido, factura, cita, despacho, cambio de plan, recordatorio de vacuna y mensaje de contacto. El recordatorio sale cada mañana a las 8:00 sin que nadie lo dispare (RN-20).</a:t>
+            </a:r>
+            <a:endParaRPr lang="en-US" sz="1200" dirty="0"/>
+          </a:p>
+        </p:txBody>
+      </p:sp>
+      <p:sp>
+        <p:nvSpPr>
+          <p:cNvPr id="12" name="Shape 10"/>
+          <p:cNvSpPr/>
+          <p:nvPr/>
+        </p:nvSpPr>
+        <p:spPr>
+          <a:xfrm>
+            <a:off x="8048549" y="1719072"/>
+            <a:ext cx="3503066" cy="2432304"/>
+          </a:xfrm>
+          <a:prstGeom prst="roundRect">
+            <a:avLst>
+              <a:gd name="adj" fmla="val 1880"/>
+            </a:avLst>
+          </a:prstGeom>
+          <a:solidFill>
+            <a:srgbClr val="EEF5F1"/>
+          </a:solidFill>
+          <a:ln w="12700">
+            <a:solidFill>
+              <a:srgbClr val="D9E5DF"/>
+            </a:solidFill>
+            <a:prstDash val="solid"/>
+          </a:ln>
+        </p:spPr>
+      </p:sp>
+      <p:sp>
+        <p:nvSpPr>
+          <p:cNvPr id="13" name="Text 11"/>
+          <p:cNvSpPr txBox="1"/>
+          <p:nvPr/>
+        </p:nvSpPr>
+        <p:spPr>
+          <a:xfrm>
+            <a:off x="8304581" y="1920240"/>
+            <a:ext cx="2991002" cy="274320"/>
+          </a:xfrm>
+          <a:prstGeom prst="rect">
+            <a:avLst/>
+          </a:prstGeom>
+          <a:noFill/>
+          <a:ln/>
+        </p:spPr>
+        <p:txBody>
+          <a:bodyPr wrap="square" lIns="0" tIns="0" rIns="0" bIns="0" rtlCol="0" anchor="ctr"/>
+          <a:lstStyle/>
+          <a:p>
+            <a:pPr indent="0" marL="0">
+              <a:buNone/>
+            </a:pPr>
+            <a:r>
+              <a:rPr lang="en-US" sz="1050" b="1" dirty="0">
+                <a:solidFill>
+                  <a:srgbClr val="E8A33D"/>
+                </a:solidFill>
+                <a:latin typeface="Calibri" pitchFamily="34" charset="0"/>
+                <a:ea typeface="Calibri" pitchFamily="34" charset="-122"/>
+                <a:cs typeface="Calibri" pitchFamily="34" charset="-120"/>
+              </a:rPr>
+              <a:t>ACCESIBILIDAD</a:t>
+            </a:r>
+            <a:endParaRPr lang="en-US" sz="1050" dirty="0"/>
+          </a:p>
+        </p:txBody>
+      </p:sp>
+      <p:sp>
+        <p:nvSpPr>
+          <p:cNvPr id="14" name="Text 12"/>
+          <p:cNvSpPr txBox="1"/>
+          <p:nvPr/>
+        </p:nvSpPr>
+        <p:spPr>
+          <a:xfrm>
+            <a:off x="8304581" y="2212848"/>
+            <a:ext cx="2991002" cy="365760"/>
+          </a:xfrm>
+          <a:prstGeom prst="rect">
+            <a:avLst/>
+          </a:prstGeom>
+          <a:noFill/>
+          <a:ln/>
+        </p:spPr>
+        <p:txBody>
+          <a:bodyPr wrap="square" lIns="0" tIns="0" rIns="0" bIns="0" rtlCol="0" anchor="ctr"/>
+          <a:lstStyle/>
+          <a:p>
+            <a:pPr indent="0" marL="0">
+              <a:buNone/>
+            </a:pPr>
+            <a:r>
+              <a:rPr lang="en-US" sz="1600" b="1" dirty="0">
+                <a:solidFill>
+                  <a:srgbClr val="14524A"/>
+                </a:solidFill>
+                <a:latin typeface="Cambria" pitchFamily="34" charset="0"/>
+                <a:ea typeface="Cambria" pitchFamily="34" charset="-122"/>
+                <a:cs typeface="Cambria" pitchFamily="34" charset="-120"/>
+              </a:rPr>
+              <a:t>Usable en el celular</a:t>
+            </a:r>
+            <a:endParaRPr lang="en-US" sz="1600" dirty="0"/>
+          </a:p>
+        </p:txBody>
+      </p:sp>
+      <p:sp>
+        <p:nvSpPr>
+          <p:cNvPr id="15" name="Text 13"/>
+          <p:cNvSpPr txBox="1"/>
+          <p:nvPr/>
+        </p:nvSpPr>
+        <p:spPr>
+          <a:xfrm>
+            <a:off x="8304581" y="2651760"/>
+            <a:ext cx="2991002" cy="1298448"/>
+          </a:xfrm>
+          <a:prstGeom prst="rect">
+            <a:avLst/>
+          </a:prstGeom>
+          <a:noFill/>
+          <a:ln/>
+        </p:spPr>
+        <p:txBody>
+          <a:bodyPr wrap="square" lIns="0" tIns="0" rIns="0" bIns="0" rtlCol="0" anchor="t"/>
+          <a:lstStyle/>
+          <a:p>
+            <a:pPr indent="0" marL="0">
+              <a:lnSpc>
+                <a:spcPts val="1740"/>
+              </a:lnSpc>
+              <a:buNone/>
+            </a:pPr>
+            <a:r>
+              <a:rPr lang="en-US" sz="1200" dirty="0">
+                <a:solidFill>
+                  <a:srgbClr val="1C2321"/>
+                </a:solidFill>
+                <a:latin typeface="Calibri" pitchFamily="34" charset="0"/>
+                <a:ea typeface="Calibri" pitchFamily="34" charset="-122"/>
+                <a:cs typeface="Calibri" pitchFamily="34" charset="-120"/>
+              </a:rPr>
+              <a:t>Las tablas se reordenan en tarjetas en pantalla chica y cada dato conserva su etiqueta para el lector de pantalla. El chat anuncia su estado con atributos ARIA (RNF-01 y RNF-06).</a:t>
+            </a:r>
+            <a:endParaRPr lang="en-US" sz="1200" dirty="0"/>
+          </a:p>
+        </p:txBody>
+      </p:sp>
+      <p:sp>
+        <p:nvSpPr>
+          <p:cNvPr id="16" name="Shape 14"/>
+          <p:cNvSpPr/>
+          <p:nvPr/>
+        </p:nvSpPr>
+        <p:spPr>
+          <a:xfrm>
+            <a:off x="640080" y="4480560"/>
+            <a:ext cx="10911535" cy="1188720"/>
+          </a:xfrm>
+          <a:prstGeom prst="roundRect">
+            <a:avLst>
+              <a:gd name="adj" fmla="val 3846"/>
             </a:avLst>
           </a:prstGeom>
           <a:solidFill>
@@ -3197,353 +3727,60 @@
       </p:sp>
       <p:sp>
         <p:nvSpPr>
-          <p:cNvPr id="5" name="Text 3"/>
-          <p:cNvSpPr txBox="1"/>
-          <p:nvPr/>
-        </p:nvSpPr>
-        <p:spPr>
-          <a:xfrm>
-            <a:off x="914400" y="1792224"/>
-            <a:ext cx="1828800" cy="877824"/>
-          </a:xfrm>
-          <a:prstGeom prst="rect">
-            <a:avLst/>
-          </a:prstGeom>
-          <a:noFill/>
-          <a:ln/>
-        </p:spPr>
-        <p:txBody>
-          <a:bodyPr wrap="square" lIns="0" tIns="0" rIns="0" bIns="0" rtlCol="0" anchor="ctr"/>
-          <a:lstStyle/>
-          <a:p>
-            <a:pPr indent="0" marL="0">
-              <a:buNone/>
-            </a:pPr>
-            <a:r>
-              <a:rPr lang="en-US" sz="5200" b="1" dirty="0">
+          <p:cNvPr id="17" name="Text 15"/>
+          <p:cNvSpPr txBox="1"/>
+          <p:nvPr/>
+        </p:nvSpPr>
+        <p:spPr>
+          <a:xfrm>
+            <a:off x="950976" y="4480560"/>
+            <a:ext cx="10289743" cy="1188720"/>
+          </a:xfrm>
+          <a:prstGeom prst="rect">
+            <a:avLst/>
+          </a:prstGeom>
+          <a:noFill/>
+          <a:ln/>
+        </p:spPr>
+        <p:txBody>
+          <a:bodyPr wrap="square" lIns="0" tIns="0" rIns="0" bIns="0" rtlCol="0" anchor="ctr"/>
+          <a:lstStyle/>
+          <a:p>
+            <a:pPr indent="0" marL="0">
+              <a:lnSpc>
+                <a:spcPts val="1700"/>
+              </a:lnSpc>
+              <a:buNone/>
+            </a:pPr>
+            <a:r>
+              <a:rPr lang="en-US" sz="1200" b="1" dirty="0">
                 <a:solidFill>
                   <a:srgbClr val="E8A33D"/>
                 </a:solidFill>
-                <a:latin typeface="Cambria" pitchFamily="34" charset="0"/>
-                <a:ea typeface="Cambria" pitchFamily="34" charset="-122"/>
-                <a:cs typeface="Cambria" pitchFamily="34" charset="-120"/>
-              </a:rPr>
-              <a:t>133</a:t>
-            </a:r>
-            <a:endParaRPr lang="en-US" sz="5200" dirty="0"/>
-          </a:p>
-        </p:txBody>
-      </p:sp>
-      <p:sp>
-        <p:nvSpPr>
-          <p:cNvPr id="6" name="Text 4"/>
-          <p:cNvSpPr txBox="1"/>
-          <p:nvPr/>
-        </p:nvSpPr>
-        <p:spPr>
-          <a:xfrm>
-            <a:off x="2743200" y="1792224"/>
-            <a:ext cx="2959456" cy="877824"/>
-          </a:xfrm>
-          <a:prstGeom prst="rect">
-            <a:avLst/>
-          </a:prstGeom>
-          <a:noFill/>
-          <a:ln/>
-        </p:spPr>
-        <p:txBody>
-          <a:bodyPr wrap="square" lIns="0" tIns="0" rIns="0" bIns="0" rtlCol="0" anchor="ctr"/>
-          <a:lstStyle/>
-          <a:p>
-            <a:pPr indent="0" marL="0">
-              <a:buNone/>
-            </a:pPr>
-            <a:r>
-              <a:rPr lang="en-US" sz="1500" b="1" dirty="0">
+                <a:latin typeface="Calibri" pitchFamily="34" charset="0"/>
+                <a:ea typeface="Calibri" pitchFamily="34" charset="-122"/>
+                <a:cs typeface="Calibri" pitchFamily="34" charset="-120"/>
+              </a:rPr>
+              <a:t xml:space="preserve">El asistente no es una caja negra.  </a:t>
+            </a:r>
+            <a:pPr indent="0" marL="0">
+              <a:lnSpc>
+                <a:spcPts val="1700"/>
+              </a:lnSpc>
+              <a:buNone/>
+            </a:pPr>
+            <a:r>
+              <a:rPr lang="en-US" sz="1200" dirty="0">
                 <a:solidFill>
                   <a:srgbClr val="FFFFFF"/>
                 </a:solidFill>
-                <a:latin typeface="Cambria" pitchFamily="34" charset="0"/>
-                <a:ea typeface="Cambria" pitchFamily="34" charset="-122"/>
-                <a:cs typeface="Cambria" pitchFamily="34" charset="-120"/>
-              </a:rPr>
-              <a:t>pruebas automatizadas</a:t>
-            </a:r>
-            <a:endParaRPr lang="en-US" sz="1500" dirty="0"/>
-          </a:p>
-        </p:txBody>
-      </p:sp>
-      <p:sp>
-        <p:nvSpPr>
-          <p:cNvPr id="7" name="Text 5"/>
-          <p:cNvSpPr txBox="1"/>
-          <p:nvPr/>
-        </p:nvSpPr>
-        <p:spPr>
-          <a:xfrm>
-            <a:off x="914400" y="2706624"/>
-            <a:ext cx="4788256" cy="676656"/>
-          </a:xfrm>
-          <a:prstGeom prst="rect">
-            <a:avLst/>
-          </a:prstGeom>
-          <a:noFill/>
-          <a:ln/>
-        </p:spPr>
-        <p:txBody>
-          <a:bodyPr wrap="square" lIns="0" tIns="0" rIns="0" bIns="0" rtlCol="0" anchor="t"/>
-          <a:lstStyle/>
-          <a:p>
-            <a:pPr indent="0" marL="0">
-              <a:lnSpc>
-                <a:spcPts val="1600"/>
-              </a:lnSpc>
-              <a:buNone/>
-            </a:pPr>
-            <a:r>
-              <a:rPr lang="en-US" sz="1150" dirty="0">
-                <a:solidFill>
-                  <a:srgbClr val="CFE3DC"/>
-                </a:solidFill>
-                <a:latin typeface="Calibri" pitchFamily="34" charset="0"/>
-                <a:ea typeface="Calibri" pitchFamily="34" charset="-122"/>
-                <a:cs typeface="Calibri" pitchFamily="34" charset="-120"/>
-              </a:rPr>
-              <a:t>336 aserciones, ejecutadas contra base de datos real y no contra una simulación. Al menos una prueba por cada una de las 22 reglas de negocio.</a:t>
-            </a:r>
-            <a:endParaRPr lang="en-US" sz="1150" dirty="0"/>
-          </a:p>
-        </p:txBody>
-      </p:sp>
-      <p:sp>
-        <p:nvSpPr>
-          <p:cNvPr id="8" name="Shape 6"/>
-          <p:cNvSpPr/>
-          <p:nvPr/>
-        </p:nvSpPr>
-        <p:spPr>
-          <a:xfrm>
-            <a:off x="6214720" y="1682496"/>
-            <a:ext cx="5336896" cy="1828800"/>
-          </a:xfrm>
-          <a:prstGeom prst="roundRect">
-            <a:avLst>
-              <a:gd name="adj" fmla="val 2500"/>
-            </a:avLst>
-          </a:prstGeom>
-          <a:solidFill>
-            <a:srgbClr val="EEF5F1"/>
-          </a:solidFill>
-          <a:ln w="12700">
-            <a:solidFill>
-              <a:srgbClr val="D9E5DF"/>
-            </a:solidFill>
-            <a:prstDash val="solid"/>
-          </a:ln>
-        </p:spPr>
-      </p:sp>
-      <p:sp>
-        <p:nvSpPr>
-          <p:cNvPr id="9" name="Text 7"/>
-          <p:cNvSpPr txBox="1"/>
-          <p:nvPr/>
-        </p:nvSpPr>
-        <p:spPr>
-          <a:xfrm>
-            <a:off x="6470752" y="1883664"/>
-            <a:ext cx="4824832" cy="274320"/>
-          </a:xfrm>
-          <a:prstGeom prst="rect">
-            <a:avLst/>
-          </a:prstGeom>
-          <a:noFill/>
-          <a:ln/>
-        </p:spPr>
-        <p:txBody>
-          <a:bodyPr wrap="square" lIns="0" tIns="0" rIns="0" bIns="0" rtlCol="0" anchor="ctr"/>
-          <a:lstStyle/>
-          <a:p>
-            <a:pPr indent="0" marL="0">
-              <a:buNone/>
-            </a:pPr>
-            <a:r>
-              <a:rPr lang="en-US" sz="1050" b="1" dirty="0">
-                <a:solidFill>
-                  <a:srgbClr val="E8A33D"/>
-                </a:solidFill>
-                <a:latin typeface="Calibri" pitchFamily="34" charset="0"/>
-                <a:ea typeface="Calibri" pitchFamily="34" charset="-122"/>
-                <a:cs typeface="Calibri" pitchFamily="34" charset="-120"/>
-              </a:rPr>
-              <a:t>POR QUÉ IMPORTA</a:t>
-            </a:r>
-            <a:endParaRPr lang="en-US" sz="1050" dirty="0"/>
-          </a:p>
-        </p:txBody>
-      </p:sp>
-      <p:sp>
-        <p:nvSpPr>
-          <p:cNvPr id="10" name="Text 8"/>
-          <p:cNvSpPr txBox="1"/>
-          <p:nvPr/>
-        </p:nvSpPr>
-        <p:spPr>
-          <a:xfrm>
-            <a:off x="6470752" y="2176272"/>
-            <a:ext cx="4824832" cy="365760"/>
-          </a:xfrm>
-          <a:prstGeom prst="rect">
-            <a:avLst/>
-          </a:prstGeom>
-          <a:noFill/>
-          <a:ln/>
-        </p:spPr>
-        <p:txBody>
-          <a:bodyPr wrap="square" lIns="0" tIns="0" rIns="0" bIns="0" rtlCol="0" anchor="ctr"/>
-          <a:lstStyle/>
-          <a:p>
-            <a:pPr indent="0" marL="0">
-              <a:buNone/>
-            </a:pPr>
-            <a:r>
-              <a:rPr lang="en-US" sz="1600" b="1" dirty="0">
-                <a:solidFill>
-                  <a:srgbClr val="14524A"/>
-                </a:solidFill>
-                <a:latin typeface="Cambria" pitchFamily="34" charset="0"/>
-                <a:ea typeface="Cambria" pitchFamily="34" charset="-122"/>
-                <a:cs typeface="Cambria" pitchFamily="34" charset="-120"/>
-              </a:rPr>
-              <a:t>La regla se vuelve a comprobar sola</a:t>
-            </a:r>
-            <a:endParaRPr lang="en-US" sz="1600" dirty="0"/>
-          </a:p>
-        </p:txBody>
-      </p:sp>
-      <p:sp>
-        <p:nvSpPr>
-          <p:cNvPr id="11" name="Text 9"/>
-          <p:cNvSpPr txBox="1"/>
-          <p:nvPr/>
-        </p:nvSpPr>
-        <p:spPr>
-          <a:xfrm>
-            <a:off x="6470752" y="2615184"/>
-            <a:ext cx="4824832" cy="694944"/>
-          </a:xfrm>
-          <a:prstGeom prst="rect">
-            <a:avLst/>
-          </a:prstGeom>
-          <a:noFill/>
-          <a:ln/>
-        </p:spPr>
-        <p:txBody>
-          <a:bodyPr wrap="square" lIns="0" tIns="0" rIns="0" bIns="0" rtlCol="0" anchor="t"/>
-          <a:lstStyle/>
-          <a:p>
-            <a:pPr indent="0" marL="0">
-              <a:lnSpc>
-                <a:spcPts val="1740"/>
-              </a:lnSpc>
-              <a:buNone/>
-            </a:pPr>
-            <a:r>
-              <a:rPr lang="en-US" sz="1200" dirty="0">
-                <a:solidFill>
-                  <a:srgbClr val="1C2321"/>
-                </a:solidFill>
-                <a:latin typeface="Calibri" pitchFamily="34" charset="0"/>
-                <a:ea typeface="Calibri" pitchFamily="34" charset="-122"/>
-                <a:cs typeface="Calibri" pitchFamily="34" charset="-120"/>
-              </a:rPr>
-              <a:t>Antes de cada entrega se ejecuta la suite completa. Si un cambio rompe una regla del negocio, se sabe en el momento y no en el reclamo del cliente.</a:t>
+                <a:latin typeface="Calibri" pitchFamily="34" charset="0"/>
+                <a:ea typeface="Calibri" pitchFamily="34" charset="-122"/>
+                <a:cs typeface="Calibri" pitchFamily="34" charset="-120"/>
+              </a:rPr>
+              <a:t>No usa inteligencia artificial externa ni servicios pagados: clasifica la pregunta con palabras clave y responde desde un único archivo de configuración. Y solo consulta los datos del cliente que está conectado, nunca los de otro (RN-01 y RN-04).</a:t>
             </a:r>
             <a:endParaRPr lang="en-US" sz="1200" dirty="0"/>
-          </a:p>
-        </p:txBody>
-      </p:sp>
-      <p:pic>
-        <p:nvPicPr>
-          <p:cNvPr id="12" name="Image 0" descr="/home/user/VetPetSurco/docs/capturas-reglas/05-carrito-bloqueado.png">    </p:cNvPr>
-          <p:cNvPicPr>
-            <a:picLocks noChangeAspect="1"/>
-          </p:cNvPicPr>
-          <p:nvPr/>
-        </p:nvPicPr>
-        <p:blipFill>
-          <a:blip r:embed="rId1"/>
-          <a:srcRect l="0" r="0" t="0" b="0"/>
-          <a:stretch/>
-        </p:blipFill>
-        <p:spPr>
-          <a:xfrm>
-            <a:off x="640080" y="3694176"/>
-            <a:ext cx="5336896" cy="2048256"/>
-          </a:xfrm>
-          <a:prstGeom prst="rect">
-            <a:avLst/>
-          </a:prstGeom>
-        </p:spPr>
-      </p:pic>
-      <p:pic>
-        <p:nvPicPr>
-          <p:cNvPr id="13" name="Image 1" descr="/home/user/VetPetSurco/docs/capturas-reglas/09-inventario.png">    </p:cNvPr>
-          <p:cNvPicPr>
-            <a:picLocks noChangeAspect="1"/>
-          </p:cNvPicPr>
-          <p:nvPr/>
-        </p:nvPicPr>
-        <p:blipFill>
-          <a:blip r:embed="rId2"/>
-          <a:srcRect l="0" r="0" t="0" b="0"/>
-          <a:stretch/>
-        </p:blipFill>
-        <p:spPr>
-          <a:xfrm>
-            <a:off x="6214720" y="3694176"/>
-            <a:ext cx="5336896" cy="2048256"/>
-          </a:xfrm>
-          <a:prstGeom prst="rect">
-            <a:avLst/>
-          </a:prstGeom>
-        </p:spPr>
-      </p:pic>
-      <p:sp>
-        <p:nvSpPr>
-          <p:cNvPr id="14" name="Text 10"/>
-          <p:cNvSpPr txBox="1"/>
-          <p:nvPr/>
-        </p:nvSpPr>
-        <p:spPr>
-          <a:xfrm>
-            <a:off x="640080" y="6327648"/>
-            <a:ext cx="10911535" cy="292608"/>
-          </a:xfrm>
-          <a:prstGeom prst="rect">
-            <a:avLst/>
-          </a:prstGeom>
-          <a:noFill/>
-          <a:ln/>
-        </p:spPr>
-        <p:txBody>
-          <a:bodyPr wrap="square" lIns="0" tIns="0" rIns="0" bIns="0" rtlCol="0" anchor="ctr"/>
-          <a:lstStyle/>
-          <a:p>
-            <a:pPr indent="0" marL="0">
-              <a:buNone/>
-            </a:pPr>
-            <a:r>
-              <a:rPr lang="en-US" sz="1000" i="1" dirty="0">
-                <a:solidFill>
-                  <a:srgbClr val="5D6B66"/>
-                </a:solidFill>
-                <a:latin typeface="Calibri" pitchFamily="34" charset="0"/>
-                <a:ea typeface="Calibri" pitchFamily="34" charset="-122"/>
-                <a:cs typeface="Calibri" pitchFamily="34" charset="-120"/>
-              </a:rPr>
-              <a:t>Capturas del sistema con la regla señalada sobre el control que la aplica: a la izquierda RN-12 bloqueando la compra sin stock, a la derecha el semáforo de reposición (RN-08).</a:t>
-            </a:r>
-            <a:endParaRPr lang="en-US" sz="1000" dirty="0"/>
           </a:p>
         </p:txBody>
       </p:sp>
@@ -3605,7 +3842,7 @@
                 <a:ea typeface="Cambria" pitchFamily="34" charset="-122"/>
                 <a:cs typeface="Cambria" pitchFamily="34" charset="-120"/>
               </a:rPr>
-              <a:t>Estado del proyecto y lo que sigue</a:t>
+              <a:t>Lo que se puede comprobar hoy</a:t>
             </a:r>
             <a:endParaRPr lang="en-US" sz="3200" dirty="0"/>
           </a:p>
@@ -3644,7 +3881,7 @@
                 <a:ea typeface="Calibri" pitchFamily="34" charset="-122"/>
                 <a:cs typeface="Calibri" pitchFamily="34" charset="-120"/>
               </a:rPr>
-              <a:t>Dónde estamos parados al cerrar este avance</a:t>
+              <a:t>No es una maqueta: es una aplicación que se ejecuta y se prueba</a:t>
             </a:r>
             <a:endParaRPr lang="en-US" sz="1400" dirty="0"/>
           </a:p>
@@ -3658,12 +3895,159 @@
         </p:nvSpPr>
         <p:spPr>
           <a:xfrm>
-            <a:off x="640080" y="1719072"/>
-            <a:ext cx="3503066" cy="2432304"/>
+            <a:off x="640080" y="1682496"/>
+            <a:ext cx="5336896" cy="1828800"/>
           </a:xfrm>
           <a:prstGeom prst="roundRect">
             <a:avLst>
-              <a:gd name="adj" fmla="val 1880"/>
+              <a:gd name="adj" fmla="val 2500"/>
+            </a:avLst>
+          </a:prstGeom>
+          <a:solidFill>
+            <a:srgbClr val="14524A"/>
+          </a:solidFill>
+          <a:ln w="12700">
+            <a:solidFill>
+              <a:srgbClr val="14524A"/>
+            </a:solidFill>
+            <a:prstDash val="solid"/>
+          </a:ln>
+        </p:spPr>
+      </p:sp>
+      <p:sp>
+        <p:nvSpPr>
+          <p:cNvPr id="5" name="Text 3"/>
+          <p:cNvSpPr txBox="1"/>
+          <p:nvPr/>
+        </p:nvSpPr>
+        <p:spPr>
+          <a:xfrm>
+            <a:off x="914400" y="1792224"/>
+            <a:ext cx="1828800" cy="877824"/>
+          </a:xfrm>
+          <a:prstGeom prst="rect">
+            <a:avLst/>
+          </a:prstGeom>
+          <a:noFill/>
+          <a:ln/>
+        </p:spPr>
+        <p:txBody>
+          <a:bodyPr wrap="square" lIns="0" tIns="0" rIns="0" bIns="0" rtlCol="0" anchor="ctr"/>
+          <a:lstStyle/>
+          <a:p>
+            <a:pPr indent="0" marL="0">
+              <a:buNone/>
+            </a:pPr>
+            <a:r>
+              <a:rPr lang="en-US" sz="5200" b="1" dirty="0">
+                <a:solidFill>
+                  <a:srgbClr val="E8A33D"/>
+                </a:solidFill>
+                <a:latin typeface="Cambria" pitchFamily="34" charset="0"/>
+                <a:ea typeface="Cambria" pitchFamily="34" charset="-122"/>
+                <a:cs typeface="Cambria" pitchFamily="34" charset="-120"/>
+              </a:rPr>
+              <a:t>137</a:t>
+            </a:r>
+            <a:endParaRPr lang="en-US" sz="5200" dirty="0"/>
+          </a:p>
+        </p:txBody>
+      </p:sp>
+      <p:sp>
+        <p:nvSpPr>
+          <p:cNvPr id="6" name="Text 4"/>
+          <p:cNvSpPr txBox="1"/>
+          <p:nvPr/>
+        </p:nvSpPr>
+        <p:spPr>
+          <a:xfrm>
+            <a:off x="2743200" y="1792224"/>
+            <a:ext cx="2959456" cy="877824"/>
+          </a:xfrm>
+          <a:prstGeom prst="rect">
+            <a:avLst/>
+          </a:prstGeom>
+          <a:noFill/>
+          <a:ln/>
+        </p:spPr>
+        <p:txBody>
+          <a:bodyPr wrap="square" lIns="0" tIns="0" rIns="0" bIns="0" rtlCol="0" anchor="ctr"/>
+          <a:lstStyle/>
+          <a:p>
+            <a:pPr indent="0" marL="0">
+              <a:buNone/>
+            </a:pPr>
+            <a:r>
+              <a:rPr lang="en-US" sz="1500" b="1" dirty="0">
+                <a:solidFill>
+                  <a:srgbClr val="FFFFFF"/>
+                </a:solidFill>
+                <a:latin typeface="Cambria" pitchFamily="34" charset="0"/>
+                <a:ea typeface="Cambria" pitchFamily="34" charset="-122"/>
+                <a:cs typeface="Cambria" pitchFamily="34" charset="-120"/>
+              </a:rPr>
+              <a:t>pruebas automatizadas</a:t>
+            </a:r>
+            <a:endParaRPr lang="en-US" sz="1500" dirty="0"/>
+          </a:p>
+        </p:txBody>
+      </p:sp>
+      <p:sp>
+        <p:nvSpPr>
+          <p:cNvPr id="7" name="Text 5"/>
+          <p:cNvSpPr txBox="1"/>
+          <p:nvPr/>
+        </p:nvSpPr>
+        <p:spPr>
+          <a:xfrm>
+            <a:off x="914400" y="2706624"/>
+            <a:ext cx="4788256" cy="676656"/>
+          </a:xfrm>
+          <a:prstGeom prst="rect">
+            <a:avLst/>
+          </a:prstGeom>
+          <a:noFill/>
+          <a:ln/>
+        </p:spPr>
+        <p:txBody>
+          <a:bodyPr wrap="square" lIns="0" tIns="0" rIns="0" bIns="0" rtlCol="0" anchor="t"/>
+          <a:lstStyle/>
+          <a:p>
+            <a:pPr indent="0" marL="0">
+              <a:lnSpc>
+                <a:spcPts val="1600"/>
+              </a:lnSpc>
+              <a:buNone/>
+            </a:pPr>
+            <a:r>
+              <a:rPr lang="en-US" sz="1150" dirty="0">
+                <a:solidFill>
+                  <a:srgbClr val="CFE3DC"/>
+                </a:solidFill>
+                <a:latin typeface="Calibri" pitchFamily="34" charset="0"/>
+                <a:ea typeface="Calibri" pitchFamily="34" charset="-122"/>
+                <a:cs typeface="Calibri" pitchFamily="34" charset="-120"/>
+              </a:rPr>
+              <a:t>346 aserciones, ejecutadas contra base de datos real y no contra una simulación. Al menos una prueba por cada una de las 22 reglas de negocio.</a:t>
+            </a:r>
+            <a:endParaRPr lang="en-US" sz="1150" dirty="0"/>
+          </a:p>
+        </p:txBody>
+      </p:sp>
+      <p:sp>
+        <p:nvSpPr>
+          <p:cNvPr id="8" name="Shape 6"/>
+          <p:cNvSpPr/>
+          <p:nvPr/>
+        </p:nvSpPr>
+        <p:spPr>
+          <a:xfrm>
+            <a:off x="6214720" y="1682496"/>
+            <a:ext cx="5336896" cy="1828800"/>
+          </a:xfrm>
+          <a:prstGeom prst="roundRect">
+            <a:avLst>
+              <a:gd name="adj" fmla="val 2500"/>
             </a:avLst>
           </a:prstGeom>
           <a:solidFill>
@@ -3679,14 +4063,14 @@
       </p:sp>
       <p:sp>
         <p:nvSpPr>
-          <p:cNvPr id="5" name="Text 3"/>
-          <p:cNvSpPr txBox="1"/>
-          <p:nvPr/>
-        </p:nvSpPr>
-        <p:spPr>
-          <a:xfrm>
-            <a:off x="896112" y="1920240"/>
-            <a:ext cx="2991002" cy="274320"/>
+          <p:cNvPr id="9" name="Text 7"/>
+          <p:cNvSpPr txBox="1"/>
+          <p:nvPr/>
+        </p:nvSpPr>
+        <p:spPr>
+          <a:xfrm>
+            <a:off x="6470752" y="1883664"/>
+            <a:ext cx="4824832" cy="274320"/>
           </a:xfrm>
           <a:prstGeom prst="rect">
             <a:avLst/>
@@ -3704,13 +4088,13 @@
             <a:r>
               <a:rPr lang="en-US" sz="1050" b="1" dirty="0">
                 <a:solidFill>
-                  <a:srgbClr val="2C7A6B"/>
-                </a:solidFill>
-                <a:latin typeface="Calibri" pitchFamily="34" charset="0"/>
-                <a:ea typeface="Calibri" pitchFamily="34" charset="-122"/>
-                <a:cs typeface="Calibri" pitchFamily="34" charset="-120"/>
-              </a:rPr>
-              <a:t>TERMINADO</a:t>
+                  <a:srgbClr val="E8A33D"/>
+                </a:solidFill>
+                <a:latin typeface="Calibri" pitchFamily="34" charset="0"/>
+                <a:ea typeface="Calibri" pitchFamily="34" charset="-122"/>
+                <a:cs typeface="Calibri" pitchFamily="34" charset="-120"/>
+              </a:rPr>
+              <a:t>POR QUÉ IMPORTA</a:t>
             </a:r>
             <a:endParaRPr lang="en-US" sz="1050" dirty="0"/>
           </a:p>
@@ -3718,14 +4102,14 @@
       </p:sp>
       <p:sp>
         <p:nvSpPr>
-          <p:cNvPr id="6" name="Text 4"/>
-          <p:cNvSpPr txBox="1"/>
-          <p:nvPr/>
-        </p:nvSpPr>
-        <p:spPr>
-          <a:xfrm>
-            <a:off x="896112" y="2212848"/>
-            <a:ext cx="2991002" cy="365760"/>
+          <p:cNvPr id="10" name="Text 8"/>
+          <p:cNvSpPr txBox="1"/>
+          <p:nvPr/>
+        </p:nvSpPr>
+        <p:spPr>
+          <a:xfrm>
+            <a:off x="6470752" y="2176272"/>
+            <a:ext cx="4824832" cy="365760"/>
           </a:xfrm>
           <a:prstGeom prst="rect">
             <a:avLst/>
@@ -3749,7 +4133,7 @@
                 <a:ea typeface="Cambria" pitchFamily="34" charset="-122"/>
                 <a:cs typeface="Cambria" pitchFamily="34" charset="-120"/>
               </a:rPr>
-              <a:t>El núcleo funciona</a:t>
+              <a:t>La regla se vuelve a comprobar sola</a:t>
             </a:r>
             <a:endParaRPr lang="en-US" sz="1600" dirty="0"/>
           </a:p>
@@ -3757,14 +4141,14 @@
       </p:sp>
       <p:sp>
         <p:nvSpPr>
-          <p:cNvPr id="7" name="Text 5"/>
-          <p:cNvSpPr txBox="1"/>
-          <p:nvPr/>
-        </p:nvSpPr>
-        <p:spPr>
-          <a:xfrm>
-            <a:off x="896112" y="2651760"/>
-            <a:ext cx="2991002" cy="1298448"/>
+          <p:cNvPr id="11" name="Text 9"/>
+          <p:cNvSpPr txBox="1"/>
+          <p:nvPr/>
+        </p:nvSpPr>
+        <p:spPr>
+          <a:xfrm>
+            <a:off x="6470752" y="2615184"/>
+            <a:ext cx="4824832" cy="694944"/>
           </a:xfrm>
           <a:prstGeom prst="rect">
             <a:avLst/>
@@ -3791,7 +4175,342 @@
                 <a:ea typeface="Calibri" pitchFamily="34" charset="-122"/>
                 <a:cs typeface="Calibri" pitchFamily="34" charset="-120"/>
               </a:rPr>
-              <a:t>Los tres perfiles, la venta con descuento de inventario, el cobro en línea, la suscripción con despacho automático, la agenda sin cruce y la historia clínica con alertas.</a:t>
+              <a:t>Antes de cada entrega se ejecuta la suite completa. Si un cambio rompe una regla del negocio, se sabe en el momento y no en el reclamo del cliente.</a:t>
+            </a:r>
+            <a:endParaRPr lang="en-US" sz="1200" dirty="0"/>
+          </a:p>
+        </p:txBody>
+      </p:sp>
+      <p:pic>
+        <p:nvPicPr>
+          <p:cNvPr id="12" name="Image 0" descr="/home/user/VetPetSurco/docs/capturas-reglas/05-carrito-bloqueado.png">    </p:cNvPr>
+          <p:cNvPicPr>
+            <a:picLocks noChangeAspect="1"/>
+          </p:cNvPicPr>
+          <p:nvPr/>
+        </p:nvPicPr>
+        <p:blipFill>
+          <a:blip r:embed="rId1"/>
+          <a:srcRect l="0" r="0" t="0" b="0"/>
+          <a:stretch/>
+        </p:blipFill>
+        <p:spPr>
+          <a:xfrm>
+            <a:off x="640080" y="3694176"/>
+            <a:ext cx="5336896" cy="2048256"/>
+          </a:xfrm>
+          <a:prstGeom prst="rect">
+            <a:avLst/>
+          </a:prstGeom>
+        </p:spPr>
+      </p:pic>
+      <p:pic>
+        <p:nvPicPr>
+          <p:cNvPr id="13" name="Image 1" descr="/home/user/VetPetSurco/docs/capturas-reglas/09-inventario.png">    </p:cNvPr>
+          <p:cNvPicPr>
+            <a:picLocks noChangeAspect="1"/>
+          </p:cNvPicPr>
+          <p:nvPr/>
+        </p:nvPicPr>
+        <p:blipFill>
+          <a:blip r:embed="rId2"/>
+          <a:srcRect l="0" r="0" t="0" b="0"/>
+          <a:stretch/>
+        </p:blipFill>
+        <p:spPr>
+          <a:xfrm>
+            <a:off x="6214720" y="3694176"/>
+            <a:ext cx="5336896" cy="2048256"/>
+          </a:xfrm>
+          <a:prstGeom prst="rect">
+            <a:avLst/>
+          </a:prstGeom>
+        </p:spPr>
+      </p:pic>
+      <p:sp>
+        <p:nvSpPr>
+          <p:cNvPr id="14" name="Text 10"/>
+          <p:cNvSpPr txBox="1"/>
+          <p:nvPr/>
+        </p:nvSpPr>
+        <p:spPr>
+          <a:xfrm>
+            <a:off x="640080" y="6327648"/>
+            <a:ext cx="10911535" cy="292608"/>
+          </a:xfrm>
+          <a:prstGeom prst="rect">
+            <a:avLst/>
+          </a:prstGeom>
+          <a:noFill/>
+          <a:ln/>
+        </p:spPr>
+        <p:txBody>
+          <a:bodyPr wrap="square" lIns="0" tIns="0" rIns="0" bIns="0" rtlCol="0" anchor="ctr"/>
+          <a:lstStyle/>
+          <a:p>
+            <a:pPr indent="0" marL="0">
+              <a:buNone/>
+            </a:pPr>
+            <a:r>
+              <a:rPr lang="en-US" sz="1000" i="1" dirty="0">
+                <a:solidFill>
+                  <a:srgbClr val="5D6B66"/>
+                </a:solidFill>
+                <a:latin typeface="Calibri" pitchFamily="34" charset="0"/>
+                <a:ea typeface="Calibri" pitchFamily="34" charset="-122"/>
+                <a:cs typeface="Calibri" pitchFamily="34" charset="-120"/>
+              </a:rPr>
+              <a:t>Capturas del sistema con la regla señalada sobre el control que la aplica: a la izquierda RN-12 bloqueando la compra sin stock, a la derecha el semáforo de reposición (RN-08).</a:t>
+            </a:r>
+            <a:endParaRPr lang="en-US" sz="1000" dirty="0"/>
+          </a:p>
+        </p:txBody>
+      </p:sp>
+    </p:spTree>
+  </p:cSld>
+  <p:clrMapOvr>
+    <a:masterClrMapping/>
+  </p:clrMapOvr>
+</p:sld>
+</file>
+
+<file path=ppt/slides/slide13.xml><?xml version="1.0" encoding="utf-8"?>
+<p:sld xmlns:a="http://schemas.openxmlformats.org/drawingml/2006/main" xmlns:r="http://schemas.openxmlformats.org/officeDocument/2006/relationships" xmlns:p="http://schemas.openxmlformats.org/presentationml/2006/main">
+  <p:cSld name="Slide 13">
+    <p:spTree>
+      <p:nvGrpSpPr>
+        <p:cNvPr id="1" name=""/>
+        <p:cNvGrpSpPr/>
+        <p:nvPr/>
+      </p:nvGrpSpPr>
+      <p:grpSpPr>
+        <a:xfrm>
+          <a:off x="0" y="0"/>
+          <a:ext cx="0" cy="0"/>
+          <a:chOff x="0" y="0"/>
+          <a:chExt cx="0" cy="0"/>
+        </a:xfrm>
+      </p:grpSpPr>
+      <p:sp>
+        <p:nvSpPr>
+          <p:cNvPr id="2" name="Text 0"/>
+          <p:cNvSpPr txBox="1"/>
+          <p:nvPr/>
+        </p:nvSpPr>
+        <p:spPr>
+          <a:xfrm>
+            <a:off x="640080" y="384048"/>
+            <a:ext cx="10911535" cy="658368"/>
+          </a:xfrm>
+          <a:prstGeom prst="rect">
+            <a:avLst/>
+          </a:prstGeom>
+          <a:noFill/>
+          <a:ln/>
+        </p:spPr>
+        <p:txBody>
+          <a:bodyPr wrap="square" lIns="0" tIns="0" rIns="0" bIns="0" rtlCol="0" anchor="ctr"/>
+          <a:lstStyle/>
+          <a:p>
+            <a:pPr indent="0" marL="0">
+              <a:buNone/>
+            </a:pPr>
+            <a:r>
+              <a:rPr lang="en-US" sz="3200" b="1" dirty="0">
+                <a:solidFill>
+                  <a:srgbClr val="14524A"/>
+                </a:solidFill>
+                <a:latin typeface="Cambria" pitchFamily="34" charset="0"/>
+                <a:ea typeface="Cambria" pitchFamily="34" charset="-122"/>
+                <a:cs typeface="Cambria" pitchFamily="34" charset="-120"/>
+              </a:rPr>
+              <a:t>Estado del proyecto y lo que sigue</a:t>
+            </a:r>
+            <a:endParaRPr lang="en-US" sz="3200" dirty="0"/>
+          </a:p>
+        </p:txBody>
+      </p:sp>
+      <p:sp>
+        <p:nvSpPr>
+          <p:cNvPr id="3" name="Text 1"/>
+          <p:cNvSpPr txBox="1"/>
+          <p:nvPr/>
+        </p:nvSpPr>
+        <p:spPr>
+          <a:xfrm>
+            <a:off x="640080" y="1042416"/>
+            <a:ext cx="10911535" cy="384048"/>
+          </a:xfrm>
+          <a:prstGeom prst="rect">
+            <a:avLst/>
+          </a:prstGeom>
+          <a:noFill/>
+          <a:ln/>
+        </p:spPr>
+        <p:txBody>
+          <a:bodyPr wrap="square" lIns="0" tIns="0" rIns="0" bIns="0" rtlCol="0" anchor="ctr"/>
+          <a:lstStyle/>
+          <a:p>
+            <a:pPr indent="0" marL="0">
+              <a:buNone/>
+            </a:pPr>
+            <a:r>
+              <a:rPr lang="en-US" sz="1400" dirty="0">
+                <a:solidFill>
+                  <a:srgbClr val="5D6B66"/>
+                </a:solidFill>
+                <a:latin typeface="Calibri" pitchFamily="34" charset="0"/>
+                <a:ea typeface="Calibri" pitchFamily="34" charset="-122"/>
+                <a:cs typeface="Calibri" pitchFamily="34" charset="-120"/>
+              </a:rPr>
+              <a:t>Dónde estamos parados al cerrar este avance</a:t>
+            </a:r>
+            <a:endParaRPr lang="en-US" sz="1400" dirty="0"/>
+          </a:p>
+        </p:txBody>
+      </p:sp>
+      <p:sp>
+        <p:nvSpPr>
+          <p:cNvPr id="4" name="Shape 2"/>
+          <p:cNvSpPr/>
+          <p:nvPr/>
+        </p:nvSpPr>
+        <p:spPr>
+          <a:xfrm>
+            <a:off x="640080" y="1719072"/>
+            <a:ext cx="3503066" cy="2432304"/>
+          </a:xfrm>
+          <a:prstGeom prst="roundRect">
+            <a:avLst>
+              <a:gd name="adj" fmla="val 1880"/>
+            </a:avLst>
+          </a:prstGeom>
+          <a:solidFill>
+            <a:srgbClr val="EEF5F1"/>
+          </a:solidFill>
+          <a:ln w="12700">
+            <a:solidFill>
+              <a:srgbClr val="D9E5DF"/>
+            </a:solidFill>
+            <a:prstDash val="solid"/>
+          </a:ln>
+        </p:spPr>
+      </p:sp>
+      <p:sp>
+        <p:nvSpPr>
+          <p:cNvPr id="5" name="Text 3"/>
+          <p:cNvSpPr txBox="1"/>
+          <p:nvPr/>
+        </p:nvSpPr>
+        <p:spPr>
+          <a:xfrm>
+            <a:off x="896112" y="1920240"/>
+            <a:ext cx="2991002" cy="274320"/>
+          </a:xfrm>
+          <a:prstGeom prst="rect">
+            <a:avLst/>
+          </a:prstGeom>
+          <a:noFill/>
+          <a:ln/>
+        </p:spPr>
+        <p:txBody>
+          <a:bodyPr wrap="square" lIns="0" tIns="0" rIns="0" bIns="0" rtlCol="0" anchor="ctr"/>
+          <a:lstStyle/>
+          <a:p>
+            <a:pPr indent="0" marL="0">
+              <a:buNone/>
+            </a:pPr>
+            <a:r>
+              <a:rPr lang="en-US" sz="1050" b="1" dirty="0">
+                <a:solidFill>
+                  <a:srgbClr val="2C7A6B"/>
+                </a:solidFill>
+                <a:latin typeface="Calibri" pitchFamily="34" charset="0"/>
+                <a:ea typeface="Calibri" pitchFamily="34" charset="-122"/>
+                <a:cs typeface="Calibri" pitchFamily="34" charset="-120"/>
+              </a:rPr>
+              <a:t>TERMINADO</a:t>
+            </a:r>
+            <a:endParaRPr lang="en-US" sz="1050" dirty="0"/>
+          </a:p>
+        </p:txBody>
+      </p:sp>
+      <p:sp>
+        <p:nvSpPr>
+          <p:cNvPr id="6" name="Text 4"/>
+          <p:cNvSpPr txBox="1"/>
+          <p:nvPr/>
+        </p:nvSpPr>
+        <p:spPr>
+          <a:xfrm>
+            <a:off x="896112" y="2212848"/>
+            <a:ext cx="2991002" cy="365760"/>
+          </a:xfrm>
+          <a:prstGeom prst="rect">
+            <a:avLst/>
+          </a:prstGeom>
+          <a:noFill/>
+          <a:ln/>
+        </p:spPr>
+        <p:txBody>
+          <a:bodyPr wrap="square" lIns="0" tIns="0" rIns="0" bIns="0" rtlCol="0" anchor="ctr"/>
+          <a:lstStyle/>
+          <a:p>
+            <a:pPr indent="0" marL="0">
+              <a:buNone/>
+            </a:pPr>
+            <a:r>
+              <a:rPr lang="en-US" sz="1600" b="1" dirty="0">
+                <a:solidFill>
+                  <a:srgbClr val="14524A"/>
+                </a:solidFill>
+                <a:latin typeface="Cambria" pitchFamily="34" charset="0"/>
+                <a:ea typeface="Cambria" pitchFamily="34" charset="-122"/>
+                <a:cs typeface="Cambria" pitchFamily="34" charset="-120"/>
+              </a:rPr>
+              <a:t>El núcleo funciona</a:t>
+            </a:r>
+            <a:endParaRPr lang="en-US" sz="1600" dirty="0"/>
+          </a:p>
+        </p:txBody>
+      </p:sp>
+      <p:sp>
+        <p:nvSpPr>
+          <p:cNvPr id="7" name="Text 5"/>
+          <p:cNvSpPr txBox="1"/>
+          <p:nvPr/>
+        </p:nvSpPr>
+        <p:spPr>
+          <a:xfrm>
+            <a:off x="896112" y="2651760"/>
+            <a:ext cx="2991002" cy="1298448"/>
+          </a:xfrm>
+          <a:prstGeom prst="rect">
+            <a:avLst/>
+          </a:prstGeom>
+          <a:noFill/>
+          <a:ln/>
+        </p:spPr>
+        <p:txBody>
+          <a:bodyPr wrap="square" lIns="0" tIns="0" rIns="0" bIns="0" rtlCol="0" anchor="t"/>
+          <a:lstStyle/>
+          <a:p>
+            <a:pPr indent="0" marL="0">
+              <a:lnSpc>
+                <a:spcPts val="1740"/>
+              </a:lnSpc>
+              <a:buNone/>
+            </a:pPr>
+            <a:r>
+              <a:rPr lang="en-US" sz="1200" dirty="0">
+                <a:solidFill>
+                  <a:srgbClr val="1C2321"/>
+                </a:solidFill>
+                <a:latin typeface="Calibri" pitchFamily="34" charset="0"/>
+                <a:ea typeface="Calibri" pitchFamily="34" charset="-122"/>
+                <a:cs typeface="Calibri" pitchFamily="34" charset="-120"/>
+              </a:rPr>
+              <a:t>Los tres perfiles, la venta con descuento de inventario, el cobro en línea, la suscripción con despacho automático, la agenda sin cruce, la historia clínica con alertas, el asistente del sitio y los correos automáticos.</a:t>
             </a:r>
             <a:endParaRPr lang="en-US" sz="1200" dirty="0"/>
           </a:p>
@@ -5141,7 +5860,7 @@
                 <a:ea typeface="Calibri" pitchFamily="34" charset="-122"/>
                 <a:cs typeface="Calibri" pitchFamily="34" charset="-120"/>
               </a:rPr>
-              <a:t>133 pruebas ejecutadas y lo que falta para producción</a:t>
+              <a:t>137 pruebas ejecutadas y lo que falta para producción</a:t>
             </a:r>
             <a:endParaRPr lang="en-US" sz="1150" dirty="0"/>
           </a:p>
@@ -10378,7 +11097,7 @@
                 <a:ea typeface="Calibri" pitchFamily="34" charset="-122"/>
                 <a:cs typeface="Calibri" pitchFamily="34" charset="-120"/>
               </a:rPr>
-              <a:t>Documento de requerimientos con 17 funcionales, 12 no funcionales y 22 reglas, más la trazabilidad a los problemas del diagnóstico.</a:t>
+              <a:t>Documento de requerimientos con 19 funcionales, 12 no funcionales y 22 reglas, más la trazabilidad a los problemas del diagnóstico.</a:t>
             </a:r>
             <a:endParaRPr lang="en-US" sz="1150" dirty="0"/>
           </a:p>
@@ -10628,7 +11347,7 @@
                 <a:ea typeface="Cambria" pitchFamily="34" charset="-122"/>
                 <a:cs typeface="Cambria" pitchFamily="34" charset="-120"/>
               </a:rPr>
-              <a:t>17</a:t>
+              <a:t>19</a:t>
             </a:r>
             <a:endParaRPr lang="en-US" sz="4200" dirty="0"/>
           </a:p>

</xml_diff>